<commit_message>
Portada: indicar modalidad virtual no presencial
Co-Authored-By: Claude Sonnet 5.5 <noreply@anthropic.com>
Claude-Session: https://claude.ai/code/session_0196T8tXAr6RMKpJodyvA85G
</commit_message>
<xml_diff>
--- a/Sesion_03_mejorada.pptx
+++ b/Sesion_03_mejorada.pptx
@@ -4141,6 +4141,91 @@
                 <a:cs typeface="Montserrat" pitchFamily="34" charset="-120"/>
               </a:rPr>
               <a:t/>
+            </a:r>
+          </a:p>
+        </p:txBody>
+      </p:sp>
+      <p:sp>
+        <p:nvSpPr>
+          <p:cNvPr id="13" name="Rounded Rectangle 12"/>
+          <p:cNvSpPr/>
+          <p:nvPr/>
+        </p:nvSpPr>
+        <p:spPr>
+          <a:xfrm>
+            <a:off x="822960" y="5303520"/>
+            <a:ext cx="4754880" cy="310896"/>
+          </a:xfrm>
+          <a:prstGeom prst="roundRect">
+            <a:avLst>
+              <a:gd name="adj" fmla="val 50000"/>
+            </a:avLst>
+          </a:prstGeom>
+          <a:solidFill>
+            <a:srgbClr val="D4AF37"/>
+          </a:solidFill>
+          <a:ln>
+            <a:noFill/>
+          </a:ln>
+          <a:effectLst/>
+        </p:spPr>
+        <p:style>
+          <a:lnRef idx="1">
+            <a:schemeClr val="accent1"/>
+          </a:lnRef>
+          <a:fillRef idx="3">
+            <a:schemeClr val="accent1"/>
+          </a:fillRef>
+          <a:effectRef idx="2">
+            <a:schemeClr val="accent1"/>
+          </a:effectRef>
+          <a:fontRef idx="minor">
+            <a:schemeClr val="lt1"/>
+          </a:fontRef>
+        </p:style>
+        <p:txBody>
+          <a:bodyPr rtlCol="0" anchor="ctr"/>
+          <a:lstStyle/>
+          <a:p>
+            <a:pPr algn="ctr"/>
+          </a:p>
+        </p:txBody>
+      </p:sp>
+      <p:sp>
+        <p:nvSpPr>
+          <p:cNvPr id="14" name="TextBox 13"/>
+          <p:cNvSpPr txBox="1"/>
+          <p:nvPr/>
+        </p:nvSpPr>
+        <p:spPr>
+          <a:xfrm>
+            <a:off x="822960" y="5303520"/>
+            <a:ext cx="4754880" cy="310896"/>
+          </a:xfrm>
+          <a:prstGeom prst="rect">
+            <a:avLst/>
+          </a:prstGeom>
+          <a:noFill/>
+        </p:spPr>
+        <p:txBody>
+          <a:bodyPr wrap="square" lIns="45720" rIns="45720" tIns="27432" bIns="27432" anchor="ctr">
+            <a:spAutoFit/>
+          </a:bodyPr>
+          <a:lstStyle/>
+          <a:p>
+            <a:pPr algn="ctr">
+              <a:spcAft>
+                <a:spcPts val="400"/>
+              </a:spcAft>
+            </a:pPr>
+            <a:r>
+              <a:rPr sz="1800" b="1" i="0">
+                <a:solidFill>
+                  <a:srgbClr val="011754"/>
+                </a:solidFill>
+                <a:latin typeface="Calibri"/>
+              </a:rPr>
+              <a:t>MODALIDAD VIRTUAL · NO PRESENCIAL</a:t>
             </a:r>
           </a:p>
         </p:txBody>

</xml_diff>

<commit_message>
Quitar etiqueta de modalidad de la portada
Co-Authored-By: Claude Sonnet 5.5 <noreply@anthropic.com>
Claude-Session: https://claude.ai/code/session_0196T8tXAr6RMKpJodyvA85G
</commit_message>
<xml_diff>
--- a/Sesion_03_mejorada.pptx
+++ b/Sesion_03_mejorada.pptx
@@ -4141,91 +4141,6 @@
                 <a:cs typeface="Montserrat" pitchFamily="34" charset="-120"/>
               </a:rPr>
               <a:t/>
-            </a:r>
-          </a:p>
-        </p:txBody>
-      </p:sp>
-      <p:sp>
-        <p:nvSpPr>
-          <p:cNvPr id="13" name="Rounded Rectangle 12"/>
-          <p:cNvSpPr/>
-          <p:nvPr/>
-        </p:nvSpPr>
-        <p:spPr>
-          <a:xfrm>
-            <a:off x="822960" y="5303520"/>
-            <a:ext cx="4754880" cy="310896"/>
-          </a:xfrm>
-          <a:prstGeom prst="roundRect">
-            <a:avLst>
-              <a:gd name="adj" fmla="val 50000"/>
-            </a:avLst>
-          </a:prstGeom>
-          <a:solidFill>
-            <a:srgbClr val="D4AF37"/>
-          </a:solidFill>
-          <a:ln>
-            <a:noFill/>
-          </a:ln>
-          <a:effectLst/>
-        </p:spPr>
-        <p:style>
-          <a:lnRef idx="1">
-            <a:schemeClr val="accent1"/>
-          </a:lnRef>
-          <a:fillRef idx="3">
-            <a:schemeClr val="accent1"/>
-          </a:fillRef>
-          <a:effectRef idx="2">
-            <a:schemeClr val="accent1"/>
-          </a:effectRef>
-          <a:fontRef idx="minor">
-            <a:schemeClr val="lt1"/>
-          </a:fontRef>
-        </p:style>
-        <p:txBody>
-          <a:bodyPr rtlCol="0" anchor="ctr"/>
-          <a:lstStyle/>
-          <a:p>
-            <a:pPr algn="ctr"/>
-          </a:p>
-        </p:txBody>
-      </p:sp>
-      <p:sp>
-        <p:nvSpPr>
-          <p:cNvPr id="14" name="TextBox 13"/>
-          <p:cNvSpPr txBox="1"/>
-          <p:nvPr/>
-        </p:nvSpPr>
-        <p:spPr>
-          <a:xfrm>
-            <a:off x="822960" y="5303520"/>
-            <a:ext cx="4754880" cy="310896"/>
-          </a:xfrm>
-          <a:prstGeom prst="rect">
-            <a:avLst/>
-          </a:prstGeom>
-          <a:noFill/>
-        </p:spPr>
-        <p:txBody>
-          <a:bodyPr wrap="square" lIns="45720" rIns="45720" tIns="27432" bIns="27432" anchor="ctr">
-            <a:spAutoFit/>
-          </a:bodyPr>
-          <a:lstStyle/>
-          <a:p>
-            <a:pPr algn="ctr">
-              <a:spcAft>
-                <a:spcPts val="400"/>
-              </a:spcAft>
-            </a:pPr>
-            <a:r>
-              <a:rPr sz="1800" b="1" i="0">
-                <a:solidFill>
-                  <a:srgbClr val="011754"/>
-                </a:solidFill>
-                <a:latin typeface="Calibri"/>
-              </a:rPr>
-              <a:t>MODALIDAD VIRTUAL · NO PRESENCIAL</a:t>
             </a:r>
           </a:p>
         </p:txBody>

</xml_diff>